<commit_message>
docs: add presentation recap and refresh docs, demo and slides
Add the recap (HTML, PDF, Markdown) to share with the deck, update the step-by-step docs and the demo-book-crud tests, and rebuild the presentation.
</commit_message>
<xml_diff>
--- a/presentation/n8n-git-linear.pptx
+++ b/presentation/n8n-git-linear.pptx
@@ -1864,8 +1864,9 @@
           <a:p>
             <a:r>
               <a:rPr lang="en-US" dirty="0"/>
-              <a:t>- Terminal pret a l'avance : branche et commit deja faits, ne jamais taper de code en direct
-- git-sync, puis basculer sur Linear et rafraichir devant la salle
+              <a:t>- AVANT TOUT : lancer ./setup-demo-book-crud.sh une fois depuis la racine du depot (recree health/loans sur le disque)
+- Terminal pret a l'avance : branche et commit deja faits, ne jamais taper de code en direct
+- git-sync (toujours simple, sans flag, meme regle pour toute la demo), puis basculer sur Linear et rafraichir devant la salle
 - Dire explicitement : aucune IA ici, juste le nom de la branche lu</a:t>
             </a:r>
             <a:endParaRPr lang="en-US" dirty="0"/>

</xml_diff>